<commit_message>
TCP vs HTTP, Multiplexing in http1.1 vs http2, keep-alive http1.1
</commit_message>
<xml_diff>
--- a/network/sir-slides/3. HTTP Protocol_ From Fundamentals to Modern Evolution.pptx
+++ b/network/sir-slides/3. HTTP Protocol_ From Fundamentals to Modern Evolution.pptx
@@ -27,17 +27,17 @@
   <p:notesSz cx="6858000" cy="12192000"/>
   <p:embeddedFontLst>
     <p:embeddedFont>
-      <p:font typeface="Microsoft Yahei" panose="020B0503020204020204" pitchFamily="34" charset="-122"/>
+      <p:font typeface="Hedvig Letters Sans" panose="020B0604020202020204" charset="0"/>
       <p:regular r:id="rId17"/>
-      <p:bold r:id="rId18"/>
-    </p:embeddedFont>
-    <p:embeddedFont>
-      <p:font typeface="Hedvig Letters Sans" panose="020B0604020202020204" charset="0"/>
-      <p:regular r:id="rId19"/>
     </p:embeddedFont>
     <p:embeddedFont>
       <p:font typeface="Liter" panose="020B0604020202020204" charset="0"/>
-      <p:regular r:id="rId20"/>
+      <p:regular r:id="rId18"/>
+    </p:embeddedFont>
+    <p:embeddedFont>
+      <p:font typeface="Microsoft Yahei" panose="020B0503020204020204" pitchFamily="34" charset="-122"/>
+      <p:regular r:id="rId19"/>
+      <p:bold r:id="rId20"/>
     </p:embeddedFont>
     <p:embeddedFont>
       <p:font typeface="Quattrocento Sans" panose="020B0502050000020003" pitchFamily="34" charset="0"/>
@@ -277,8 +277,11 @@
     </a:lvl9pPr>
   </p:defaultTextStyle>
   <p:extLst>
+    <p:ext uri="{EFAFB233-063F-42B5-8137-9DF3F51BA10A}">
+      <p15:sldGuideLst xmlns:p15="http://schemas.microsoft.com/office/powerpoint/2012/main"/>
+    </p:ext>
     <p:ext uri="GoogleSlidesCustomDataVersion2">
-      <go:slidesCustomData xmlns:go="http://customooxmlschemas.google.com/" xmlns:ahyp="http://schemas.microsoft.com/office/drawing/2018/hyperlinkcolor" xmlns:p15="http://schemas.microsoft.com/office/powerpoint/2012/main" xmlns:p14="http://schemas.microsoft.com/office/powerpoint/2010/main" xmlns:com="http://schemas.openxmlformats.org/drawingml/2006/compatibility" xmlns:pvml="urn:schemas-microsoft-com:office:powerpoint" xmlns:v="urn:schemas-microsoft-com:vml" xmlns:o="urn:schemas-microsoft-com:office:office" xmlns:dgm="http://schemas.openxmlformats.org/drawingml/2006/diagram" xmlns:c="http://schemas.openxmlformats.org/drawingml/2006/chart" xmlns:mv="urn:schemas-microsoft-com:mac:vml" xmlns:mc="http://schemas.openxmlformats.org/markup-compatibility/2006" xmlns="" r:id="rId26" roundtripDataSignature="AMtx7mgnoFNwFO5TLHagq12mb4X6f1mkKw=="/>
+      <go:slidesCustomData xmlns="" xmlns:mc="http://schemas.openxmlformats.org/markup-compatibility/2006" xmlns:mv="urn:schemas-microsoft-com:mac:vml" xmlns:c="http://schemas.openxmlformats.org/drawingml/2006/chart" xmlns:dgm="http://schemas.openxmlformats.org/drawingml/2006/diagram" xmlns:o="urn:schemas-microsoft-com:office:office" xmlns:v="urn:schemas-microsoft-com:vml" xmlns:pvml="urn:schemas-microsoft-com:office:powerpoint" xmlns:com="http://schemas.openxmlformats.org/drawingml/2006/compatibility" xmlns:p14="http://schemas.microsoft.com/office/powerpoint/2010/main" xmlns:p15="http://schemas.microsoft.com/office/powerpoint/2012/main" xmlns:ahyp="http://schemas.microsoft.com/office/drawing/2018/hyperlinkcolor" xmlns:go="http://customooxmlschemas.google.com/" r:id="rId26" roundtripDataSignature="AMtx7mgnoFNwFO5TLHagq12mb4X6f1mkKw=="/>
     </p:ext>
   </p:extLst>
 </p:presentation>
@@ -5647,7 +5650,7 @@
               <a:buNone/>
             </a:pPr>
             <a:r>
-              <a:rPr lang="en-US" sz="2581" b="1" i="0" u="none" strike="noStrike" cap="none">
+              <a:rPr lang="en-US" sz="2581" b="1" i="0" u="none" strike="noStrike" cap="none" dirty="0">
                 <a:solidFill>
                   <a:srgbClr val="E0E2E5"/>
                 </a:solidFill>
@@ -5658,7 +5661,7 @@
               </a:rPr>
               <a:t>HTTP/1.1: The Workhorse of the Web (1997-2015)</a:t>
             </a:r>
-            <a:endParaRPr sz="1600" b="0" i="0" u="none" strike="noStrike" cap="none"/>
+            <a:endParaRPr sz="1600" b="0" i="0" u="none" strike="noStrike" cap="none" dirty="0"/>
           </a:p>
         </p:txBody>
       </p:sp>
@@ -5994,7 +5997,7 @@
               <a:buNone/>
             </a:pPr>
             <a:r>
-              <a:rPr lang="en-US" sz="1147" b="0" i="0" u="none" strike="noStrike" cap="none">
+              <a:rPr lang="en-US" sz="1147" b="0" i="0" u="none" strike="noStrike" cap="none" dirty="0">
                 <a:solidFill>
                   <a:srgbClr val="B89A6B"/>
                 </a:solidFill>
@@ -6005,7 +6008,7 @@
               </a:rPr>
               <a:t>1997 • RFC 2068/2616</a:t>
             </a:r>
-            <a:endParaRPr sz="1600" b="0" i="0" u="none" strike="noStrike" cap="none"/>
+            <a:endParaRPr sz="1600" b="0" i="0" u="none" strike="noStrike" cap="none" dirty="0"/>
           </a:p>
         </p:txBody>
       </p:sp>
@@ -6777,7 +6780,7 @@
               <a:buNone/>
             </a:pPr>
             <a:r>
-              <a:rPr lang="en-US" sz="1147" b="1" i="0" u="none" strike="noStrike" cap="none">
+              <a:rPr lang="en-US" sz="1147" b="1" i="0" u="none" strike="noStrike" cap="none" dirty="0">
                 <a:solidFill>
                   <a:srgbClr val="E0E2E5"/>
                 </a:solidFill>
@@ -6788,7 +6791,7 @@
               </a:rPr>
               <a:t>Pipelining</a:t>
             </a:r>
-            <a:endParaRPr sz="1600" b="0" i="0" u="none" strike="noStrike" cap="none"/>
+            <a:endParaRPr sz="1600" b="0" i="0" u="none" strike="noStrike" cap="none" dirty="0"/>
           </a:p>
         </p:txBody>
       </p:sp>
@@ -6830,7 +6833,7 @@
               <a:buNone/>
             </a:pPr>
             <a:r>
-              <a:rPr lang="en-US" sz="1147" b="0" i="0" u="none" strike="noStrike" cap="none">
+              <a:rPr lang="en-US" sz="1147" b="0" i="0" u="none" strike="noStrike" cap="none" dirty="0">
                 <a:solidFill>
                   <a:srgbClr val="E0E2E5"/>
                 </a:solidFill>
@@ -6841,7 +6844,7 @@
               </a:rPr>
               <a:t>Send multiple requests without waiting for previous responses</a:t>
             </a:r>
-            <a:endParaRPr sz="1600" b="0" i="0" u="none" strike="noStrike" cap="none"/>
+            <a:endParaRPr sz="1600" b="0" i="0" u="none" strike="noStrike" cap="none" dirty="0"/>
           </a:p>
         </p:txBody>
       </p:sp>
@@ -7202,7 +7205,7 @@
               <a:buNone/>
             </a:pPr>
             <a:r>
-              <a:rPr lang="en-US" sz="1147" b="1" i="0" u="none" strike="noStrike" cap="none">
+              <a:rPr lang="en-US" sz="1147" b="1" i="0" u="none" strike="noStrike" cap="none" dirty="0">
                 <a:solidFill>
                   <a:srgbClr val="E0E2E5"/>
                 </a:solidFill>
@@ -7213,7 +7216,7 @@
               </a:rPr>
               <a:t>Host Header</a:t>
             </a:r>
-            <a:endParaRPr sz="1600" b="0" i="0" u="none" strike="noStrike" cap="none"/>
+            <a:endParaRPr sz="1600" b="0" i="0" u="none" strike="noStrike" cap="none" dirty="0"/>
           </a:p>
         </p:txBody>
       </p:sp>
@@ -9650,7 +9653,7 @@
               <a:buNone/>
             </a:pPr>
             <a:r>
-              <a:rPr lang="en-US" sz="1147" b="1" i="0" u="none" strike="noStrike" cap="none">
+              <a:rPr lang="en-US" sz="1147" b="1" i="0" u="none" strike="noStrike" cap="none" dirty="0">
                 <a:solidFill>
                   <a:srgbClr val="E0E2E5"/>
                 </a:solidFill>
@@ -9661,7 +9664,7 @@
               </a:rPr>
               <a:t>HTTP/1.1: Pipelined</a:t>
             </a:r>
-            <a:endParaRPr sz="1600" b="0" i="0" u="none" strike="noStrike" cap="none"/>
+            <a:endParaRPr sz="1600" b="0" i="0" u="none" strike="noStrike" cap="none" dirty="0"/>
           </a:p>
         </p:txBody>
       </p:sp>
@@ -9961,7 +9964,7 @@
               <a:buNone/>
             </a:pPr>
             <a:r>
-              <a:rPr lang="en-US" sz="1004" b="0" i="0" u="none" strike="noStrike" cap="none">
+              <a:rPr lang="en-US" sz="1004" b="0" i="0" u="none" strike="noStrike" cap="none" dirty="0">
                 <a:solidFill>
                   <a:srgbClr val="788A9C"/>
                 </a:solidFill>
@@ -9972,7 +9975,7 @@
               </a:rPr>
               <a:t>Multiple requests sent without waiting</a:t>
             </a:r>
-            <a:endParaRPr sz="1600" b="0" i="0" u="none" strike="noStrike" cap="none"/>
+            <a:endParaRPr sz="1600" b="0" i="0" u="none" strike="noStrike" cap="none" dirty="0"/>
           </a:p>
         </p:txBody>
       </p:sp>
@@ -10437,7 +10440,7 @@
               <a:buNone/>
             </a:pPr>
             <a:r>
-              <a:rPr lang="en-US" sz="1147" b="1" i="0" u="none" strike="noStrike" cap="none">
+              <a:rPr lang="en-US" sz="1147" b="1" i="0" u="none" strike="noStrike" cap="none" dirty="0">
                 <a:solidFill>
                   <a:srgbClr val="E0E2E5"/>
                 </a:solidFill>
@@ -10449,7 +10452,7 @@
               <a:t>Head-of-Line Blocking:</a:t>
             </a:r>
             <a:r>
-              <a:rPr lang="en-US" sz="1147" b="0" i="0" u="none" strike="noStrike" cap="none">
+              <a:rPr lang="en-US" sz="1147" b="0" i="0" u="none" strike="noStrike" cap="none" dirty="0">
                 <a:solidFill>
                   <a:srgbClr val="E0E2E5"/>
                 </a:solidFill>
@@ -10460,7 +10463,7 @@
               </a:rPr>
               <a:t> One delayed request blocks all subsequent requests</a:t>
             </a:r>
-            <a:endParaRPr sz="1600" b="0" i="0" u="none" strike="noStrike" cap="none"/>
+            <a:endParaRPr sz="1600" b="0" i="0" u="none" strike="noStrike" cap="none" dirty="0"/>
           </a:p>
         </p:txBody>
       </p:sp>
@@ -10642,7 +10645,7 @@
               <a:buNone/>
             </a:pPr>
             <a:r>
-              <a:rPr lang="en-US" sz="1147" b="1" i="0" u="none" strike="noStrike" cap="none">
+              <a:rPr lang="en-US" sz="1147" b="1" i="0" u="none" strike="noStrike" cap="none" dirty="0">
                 <a:solidFill>
                   <a:srgbClr val="E0E2E5"/>
                 </a:solidFill>
@@ -10654,7 +10657,7 @@
               <a:t>No Multiplexing:</a:t>
             </a:r>
             <a:r>
-              <a:rPr lang="en-US" sz="1147" b="0" i="0" u="none" strike="noStrike" cap="none">
+              <a:rPr lang="en-US" sz="1147" b="0" i="0" u="none" strike="noStrike" cap="none" dirty="0">
                 <a:solidFill>
                   <a:srgbClr val="E0E2E5"/>
                 </a:solidFill>
@@ -10665,7 +10668,7 @@
               </a:rPr>
               <a:t> Responses must return in order</a:t>
             </a:r>
-            <a:endParaRPr sz="1600" b="0" i="0" u="none" strike="noStrike" cap="none"/>
+            <a:endParaRPr sz="1600" b="0" i="0" u="none" strike="noStrike" cap="none" dirty="0"/>
           </a:p>
         </p:txBody>
       </p:sp>
@@ -41929,7 +41932,7 @@
         </p:nvSpPr>
         <p:spPr>
           <a:xfrm>
-            <a:off x="336000" y="2664000"/>
+            <a:off x="377080" y="2712000"/>
             <a:ext cx="3472000" cy="2896000"/>
           </a:xfrm>
           <a:custGeom>
@@ -42423,7 +42426,7 @@
               <a:buNone/>
             </a:pPr>
             <a:r>
-              <a:rPr lang="en-US" sz="1008" b="0" i="0" u="none" strike="noStrike" cap="none">
+              <a:rPr lang="en-US" sz="1008" b="0" i="0" u="none" strike="noStrike" cap="none" dirty="0">
                 <a:solidFill>
                   <a:srgbClr val="E0E2E5"/>
                 </a:solidFill>
@@ -42435,7 +42438,37 @@
               <a:t>HTTP operates at the </a:t>
             </a:r>
             <a:r>
-              <a:rPr lang="en-US" sz="1008" b="1" i="0" u="none" strike="noStrike" cap="none">
+              <a:rPr lang="en-US" sz="1008" b="1" i="0" u="none" strike="noStrike" cap="none" dirty="0">
+                <a:solidFill>
+                  <a:srgbClr val="E0E2E5"/>
+                </a:solidFill>
+                <a:highlight>
+                  <a:srgbClr val="008000"/>
+                </a:highlight>
+                <a:latin typeface="Quattrocento Sans"/>
+                <a:ea typeface="Quattrocento Sans"/>
+                <a:cs typeface="Quattrocento Sans"/>
+                <a:sym typeface="Quattrocento Sans"/>
+              </a:rPr>
+              <a:t>Application Layer</a:t>
+            </a:r>
+            <a:r>
+              <a:rPr lang="en-US" sz="1008" b="0" i="0" u="none" strike="noStrike" cap="none" dirty="0">
+                <a:solidFill>
+                  <a:srgbClr val="E0E2E5"/>
+                </a:solidFill>
+                <a:highlight>
+                  <a:srgbClr val="008000"/>
+                </a:highlight>
+                <a:latin typeface="Quattrocento Sans"/>
+                <a:ea typeface="Quattrocento Sans"/>
+                <a:cs typeface="Quattrocento Sans"/>
+                <a:sym typeface="Quattrocento Sans"/>
+              </a:rPr>
+              <a:t> </a:t>
+            </a:r>
+            <a:r>
+              <a:rPr lang="en-US" sz="1008" b="0" i="0" u="none" strike="noStrike" cap="none" dirty="0">
                 <a:solidFill>
                   <a:srgbClr val="E0E2E5"/>
                 </a:solidFill>
@@ -42444,21 +42477,9 @@
                 <a:cs typeface="Quattrocento Sans"/>
                 <a:sym typeface="Quattrocento Sans"/>
               </a:rPr>
-              <a:t>Application Layer</a:t>
+              <a:t>of the network stack, using TCP for data transfer (QUIC in HTTP/3).</a:t>
             </a:r>
-            <a:r>
-              <a:rPr lang="en-US" sz="1008" b="0" i="0" u="none" strike="noStrike" cap="none">
-                <a:solidFill>
-                  <a:srgbClr val="E0E2E5"/>
-                </a:solidFill>
-                <a:latin typeface="Quattrocento Sans"/>
-                <a:ea typeface="Quattrocento Sans"/>
-                <a:cs typeface="Quattrocento Sans"/>
-                <a:sym typeface="Quattrocento Sans"/>
-              </a:rPr>
-              <a:t> of the network stack, using TCP for data transfer (QUIC in HTTP/3).</a:t>
-            </a:r>
-            <a:endParaRPr sz="1600" b="0" i="0" u="none" strike="noStrike" cap="none"/>
+            <a:endParaRPr sz="1600" b="0" i="0" u="none" strike="noStrike" cap="none" dirty="0"/>
           </a:p>
         </p:txBody>
       </p:sp>
@@ -43286,7 +43307,7 @@
               <a:buNone/>
             </a:pPr>
             <a:r>
-              <a:rPr lang="en-US" sz="1008" b="0" i="0" u="none" strike="noStrike" cap="none">
+              <a:rPr lang="en-US" sz="1008" b="1" i="0" u="none" strike="noStrike" cap="none" dirty="0">
                 <a:solidFill>
                   <a:srgbClr val="E0E2E5"/>
                 </a:solidFill>
@@ -43298,7 +43319,7 @@
               <a:t>HTTP is </a:t>
             </a:r>
             <a:r>
-              <a:rPr lang="en-US" sz="1008" b="1" i="0" u="none" strike="noStrike" cap="none">
+              <a:rPr lang="en-US" sz="1008" b="1" i="0" u="none" strike="noStrike" cap="none" dirty="0">
                 <a:solidFill>
                   <a:srgbClr val="B89A6B"/>
                 </a:solidFill>
@@ -43310,7 +43331,7 @@
               <a:t>stateless</a:t>
             </a:r>
             <a:r>
-              <a:rPr lang="en-US" sz="1008" b="0" i="0" u="none" strike="noStrike" cap="none">
+              <a:rPr lang="en-US" sz="1008" b="1" i="0" u="none" strike="noStrike" cap="none" dirty="0">
                 <a:solidFill>
                   <a:srgbClr val="E0E2E5"/>
                 </a:solidFill>
@@ -43319,9 +43340,58 @@
                 <a:cs typeface="Quattrocento Sans"/>
                 <a:sym typeface="Quattrocento Sans"/>
               </a:rPr>
-              <a:t>—it doesn't store information about previous requests. This design enables easy scaling but requires mechanisms like cookies, sessions, or tokens to maintain state in web applications.</a:t>
+              <a:t>—</a:t>
             </a:r>
-            <a:endParaRPr sz="1600" b="0" i="0" u="none" strike="noStrike" cap="none"/>
+            <a:r>
+              <a:rPr lang="en-US" sz="1008" b="1" i="0" u="none" strike="noStrike" cap="none" dirty="0">
+                <a:solidFill>
+                  <a:srgbClr val="E0E2E5"/>
+                </a:solidFill>
+                <a:highlight>
+                  <a:srgbClr val="008000"/>
+                </a:highlight>
+                <a:latin typeface="Quattrocento Sans"/>
+                <a:ea typeface="Quattrocento Sans"/>
+                <a:cs typeface="Quattrocento Sans"/>
+                <a:sym typeface="Quattrocento Sans"/>
+              </a:rPr>
+              <a:t>it doesn't store information about previous requests</a:t>
+            </a:r>
+            <a:r>
+              <a:rPr lang="en-US" sz="1008" b="0" i="0" u="none" strike="noStrike" cap="none" dirty="0">
+                <a:solidFill>
+                  <a:srgbClr val="E0E2E5"/>
+                </a:solidFill>
+                <a:latin typeface="Quattrocento Sans"/>
+                <a:ea typeface="Quattrocento Sans"/>
+                <a:cs typeface="Quattrocento Sans"/>
+                <a:sym typeface="Quattrocento Sans"/>
+              </a:rPr>
+              <a:t>. This design enables easy scaling but requires mechanisms like cookies, sessions, or tokens to maintain state in web applications. </a:t>
+            </a:r>
+            <a:r>
+              <a:rPr lang="en-US" sz="1008" b="1" i="0" u="none" strike="noStrike" cap="none" dirty="0">
+                <a:solidFill>
+                  <a:schemeClr val="accent4">
+                    <a:lumMod val="60000"/>
+                    <a:lumOff val="40000"/>
+                  </a:schemeClr>
+                </a:solidFill>
+                <a:latin typeface="Quattrocento Sans"/>
+                <a:ea typeface="Quattrocento Sans"/>
+                <a:cs typeface="Quattrocento Sans"/>
+                <a:sym typeface="Quattrocento Sans"/>
+              </a:rPr>
+              <a:t>*** IMPORTANT POINT</a:t>
+            </a:r>
+            <a:endParaRPr sz="1600" b="1" i="0" u="none" strike="noStrike" cap="none" dirty="0">
+              <a:solidFill>
+                <a:schemeClr val="accent4">
+                  <a:lumMod val="60000"/>
+                  <a:lumOff val="40000"/>
+                </a:schemeClr>
+              </a:solidFill>
+            </a:endParaRPr>
           </a:p>
         </p:txBody>
       </p:sp>
@@ -44249,8 +44319,8 @@
         </p:nvSpPr>
         <p:spPr>
           <a:xfrm>
-            <a:off x="9269625" y="3176000"/>
-            <a:ext cx="1040000" cy="160000"/>
+            <a:off x="9245625" y="3129500"/>
+            <a:ext cx="1040000" cy="253000"/>
           </a:xfrm>
           <a:prstGeom prst="rect">
             <a:avLst/>
@@ -44279,7 +44349,7 @@
               <a:buNone/>
             </a:pPr>
             <a:r>
-              <a:rPr lang="en-US" sz="882" b="1" i="0" u="none" strike="noStrike" cap="none">
+              <a:rPr lang="en-US" sz="882" b="1" i="0" u="none" strike="noStrike" cap="none" dirty="0">
                 <a:solidFill>
                   <a:srgbClr val="4A6C8C"/>
                 </a:solidFill>
@@ -44290,7 +44360,19 @@
               </a:rPr>
               <a:t>Path</a:t>
             </a:r>
-            <a:endParaRPr sz="1600" b="0" i="0" u="none" strike="noStrike" cap="none"/>
+            <a:r>
+              <a:rPr lang="en-US" sz="800" b="1" i="0" u="none" strike="noStrike" cap="none" dirty="0">
+                <a:solidFill>
+                  <a:srgbClr val="4A6C8C"/>
+                </a:solidFill>
+                <a:latin typeface="Quattrocento Sans"/>
+                <a:ea typeface="Quattrocento Sans"/>
+                <a:cs typeface="Quattrocento Sans"/>
+                <a:sym typeface="Quattrocento Sans"/>
+              </a:rPr>
+              <a:t>(which server hit)</a:t>
+            </a:r>
+            <a:endParaRPr sz="1600" b="0" i="0" u="none" strike="noStrike" cap="none" dirty="0"/>
           </a:p>
         </p:txBody>
       </p:sp>
@@ -44302,7 +44384,7 @@
         </p:nvSpPr>
         <p:spPr>
           <a:xfrm>
-            <a:off x="9273625" y="3368000"/>
+            <a:off x="9253625" y="3414500"/>
             <a:ext cx="1032000" cy="128000"/>
           </a:xfrm>
           <a:prstGeom prst="rect">
@@ -44332,7 +44414,7 @@
               <a:buNone/>
             </a:pPr>
             <a:r>
-              <a:rPr lang="en-US" sz="756" b="0" i="0" u="none" strike="noStrike" cap="none">
+              <a:rPr lang="en-US" sz="756" b="0" i="0" u="none" strike="noStrike" cap="none" dirty="0">
                 <a:solidFill>
                   <a:srgbClr val="E0E2E5"/>
                 </a:solidFill>
@@ -44343,7 +44425,7 @@
               </a:rPr>
               <a:t>Resource location</a:t>
             </a:r>
-            <a:endParaRPr sz="1600" b="0" i="0" u="none" strike="noStrike" cap="none"/>
+            <a:endParaRPr sz="1600" b="0" i="0" u="none" strike="noStrike" cap="none" dirty="0"/>
           </a:p>
         </p:txBody>
       </p:sp>
@@ -44794,7 +44876,7 @@
               </a:spcAft>
               <a:buNone/>
             </a:pPr>
-            <a:endParaRPr/>
+            <a:endParaRPr dirty="0"/>
           </a:p>
         </p:txBody>
       </p:sp>
@@ -44860,7 +44942,7 @@
         <p:spPr>
           <a:xfrm>
             <a:off x="8651375" y="4664000"/>
-            <a:ext cx="258375" cy="128000"/>
+            <a:ext cx="985385" cy="104000"/>
           </a:xfrm>
           <a:prstGeom prst="rect">
             <a:avLst/>
@@ -44889,7 +44971,7 @@
               <a:buNone/>
             </a:pPr>
             <a:r>
-              <a:rPr lang="en-US" sz="882" b="0" i="0" u="none" strike="noStrike" cap="none">
+              <a:rPr lang="en-US" sz="882" b="0" i="0" u="none" strike="noStrike" cap="none" dirty="0">
                 <a:solidFill>
                   <a:srgbClr val="B89A6B"/>
                 </a:solidFill>
@@ -44898,9 +44980,9 @@
                 <a:cs typeface="Arial"/>
                 <a:sym typeface="Arial"/>
               </a:rPr>
-              <a:t>200</a:t>
+              <a:t>200(status code)</a:t>
             </a:r>
-            <a:endParaRPr sz="1600" b="0" i="0" u="none" strike="noStrike" cap="none"/>
+            <a:endParaRPr sz="1600" b="0" i="0" u="none" strike="noStrike" cap="none" dirty="0"/>
           </a:p>
         </p:txBody>
       </p:sp>
@@ -44912,7 +44994,7 @@
         </p:nvSpPr>
         <p:spPr>
           <a:xfrm>
-            <a:off x="8921250" y="4664000"/>
+            <a:off x="9625500" y="4662520"/>
             <a:ext cx="190875" cy="128000"/>
           </a:xfrm>
           <a:prstGeom prst="rect">
@@ -44942,7 +45024,7 @@
               <a:buNone/>
             </a:pPr>
             <a:r>
-              <a:rPr lang="en-US" sz="882" b="0" i="0" u="none" strike="noStrike" cap="none">
+              <a:rPr lang="en-US" sz="882" b="0" i="0" u="none" strike="noStrike" cap="none" dirty="0">
                 <a:solidFill>
                   <a:srgbClr val="E0E2E5"/>
                 </a:solidFill>
@@ -44953,7 +45035,7 @@
               </a:rPr>
               <a:t>OK</a:t>
             </a:r>
-            <a:endParaRPr sz="1600" b="0" i="0" u="none" strike="noStrike" cap="none"/>
+            <a:endParaRPr sz="1600" b="0" i="0" u="none" strike="noStrike" cap="none" dirty="0"/>
           </a:p>
         </p:txBody>
       </p:sp>
@@ -46883,7 +46965,7 @@
               <a:buNone/>
             </a:pPr>
             <a:r>
-              <a:rPr lang="en-US" sz="2250" b="1" i="0" u="none" strike="noStrike" cap="none">
+              <a:rPr lang="en-US" sz="2250" b="1" i="0" u="none" strike="noStrike" cap="none" dirty="0">
                 <a:solidFill>
                   <a:srgbClr val="E0E2E5"/>
                 </a:solidFill>
@@ -46894,7 +46976,7 @@
               </a:rPr>
               <a:t>HTTP/0.9 &amp; HTTP/1.0: The Early Days (1991-1996)</a:t>
             </a:r>
-            <a:endParaRPr sz="1600" b="0" i="0" u="none" strike="noStrike" cap="none"/>
+            <a:endParaRPr sz="1600" b="0" i="0" u="none" strike="noStrike" cap="none" dirty="0"/>
           </a:p>
         </p:txBody>
       </p:sp>
@@ -47177,7 +47259,7 @@
               <a:buNone/>
             </a:pPr>
             <a:r>
-              <a:rPr lang="en-US" sz="1500" b="1" i="0" u="none" strike="noStrike" cap="none">
+              <a:rPr lang="en-US" sz="1500" b="1" i="0" u="none" strike="noStrike" cap="none" dirty="0">
                 <a:solidFill>
                   <a:srgbClr val="E0E2E5"/>
                 </a:solidFill>
@@ -47188,7 +47270,7 @@
               </a:rPr>
               <a:t>HTTP/0.9</a:t>
             </a:r>
-            <a:endParaRPr sz="1600" b="0" i="0" u="none" strike="noStrike" cap="none"/>
+            <a:endParaRPr sz="1600" b="0" i="0" u="none" strike="noStrike" cap="none" dirty="0"/>
           </a:p>
         </p:txBody>
       </p:sp>
@@ -47767,7 +47849,7 @@
               <a:buNone/>
             </a:pPr>
             <a:r>
-              <a:rPr lang="en-US" sz="1000" b="1" i="0" u="none" strike="noStrike" cap="none">
+              <a:rPr lang="en-US" sz="1000" b="1" i="0" u="none" strike="noStrike" cap="none" dirty="0">
                 <a:solidFill>
                   <a:srgbClr val="E0E2E5"/>
                 </a:solidFill>
@@ -47779,7 +47861,7 @@
               <a:t>One request per connection:</a:t>
             </a:r>
             <a:r>
-              <a:rPr lang="en-US" sz="1000" b="0" i="0" u="none" strike="noStrike" cap="none">
+              <a:rPr lang="en-US" sz="1000" b="0" i="0" u="none" strike="noStrike" cap="none" dirty="0">
                 <a:solidFill>
                   <a:srgbClr val="E0E2E5"/>
                 </a:solidFill>
@@ -47790,7 +47872,7 @@
               </a:rPr>
               <a:t> Connection closed after each response</a:t>
             </a:r>
-            <a:endParaRPr sz="1600" b="0" i="0" u="none" strike="noStrike" cap="none"/>
+            <a:endParaRPr sz="1600" b="0" i="0" u="none" strike="noStrike" cap="none" dirty="0"/>
           </a:p>
         </p:txBody>
       </p:sp>
@@ -47926,7 +48008,7 @@
               <a:buNone/>
             </a:pPr>
             <a:r>
-              <a:rPr lang="en-US" sz="875" b="0" i="0" u="none" strike="noStrike" cap="none">
+              <a:rPr lang="en-US" sz="875" b="0" i="0" u="none" strike="noStrike" cap="none" dirty="0">
                 <a:solidFill>
                   <a:srgbClr val="B89A6B"/>
                 </a:solidFill>
@@ -47937,7 +48019,7 @@
               </a:rPr>
               <a:t>GET</a:t>
             </a:r>
-            <a:endParaRPr sz="1600" b="0" i="0" u="none" strike="noStrike" cap="none"/>
+            <a:endParaRPr sz="1600" b="0" i="0" u="none" strike="noStrike" cap="none" dirty="0"/>
           </a:p>
         </p:txBody>
       </p:sp>
@@ -47979,7 +48061,7 @@
               <a:buNone/>
             </a:pPr>
             <a:r>
-              <a:rPr lang="en-US" sz="875" b="0" i="0" u="none" strike="noStrike" cap="none">
+              <a:rPr lang="en-US" sz="875" b="0" i="0" u="none" strike="noStrike" cap="none" dirty="0">
                 <a:solidFill>
                   <a:srgbClr val="788A9C"/>
                 </a:solidFill>
@@ -47990,7 +48072,7 @@
               </a:rPr>
               <a:t>/index.html</a:t>
             </a:r>
-            <a:endParaRPr sz="1600" b="0" i="0" u="none" strike="noStrike" cap="none"/>
+            <a:endParaRPr sz="1600" b="0" i="0" u="none" strike="noStrike" cap="none" dirty="0"/>
           </a:p>
         </p:txBody>
       </p:sp>
@@ -48519,7 +48601,7 @@
               <a:buNone/>
             </a:pPr>
             <a:r>
-              <a:rPr lang="en-US" sz="1000" b="1" i="0" u="none" strike="noStrike" cap="none">
+              <a:rPr lang="en-US" sz="1000" b="1" i="0" u="none" strike="noStrike" cap="none" dirty="0">
                 <a:solidFill>
                   <a:srgbClr val="E0E2E5"/>
                 </a:solidFill>
@@ -48531,7 +48613,7 @@
               <a:t>Status codes:</a:t>
             </a:r>
             <a:r>
-              <a:rPr lang="en-US" sz="1000" b="0" i="0" u="none" strike="noStrike" cap="none">
+              <a:rPr lang="en-US" sz="1000" b="0" i="0" u="none" strike="noStrike" cap="none" dirty="0">
                 <a:solidFill>
                   <a:srgbClr val="E0E2E5"/>
                 </a:solidFill>
@@ -48542,7 +48624,7 @@
               </a:rPr>
               <a:t> 200, 404, 500</a:t>
             </a:r>
-            <a:endParaRPr sz="1600" b="0" i="0" u="none" strike="noStrike" cap="none"/>
+            <a:endParaRPr sz="1600" b="0" i="0" u="none" strike="noStrike" cap="none" dirty="0"/>
           </a:p>
         </p:txBody>
       </p:sp>
@@ -48724,7 +48806,7 @@
               <a:buNone/>
             </a:pPr>
             <a:r>
-              <a:rPr lang="en-US" sz="1000" b="1" i="0" u="none" strike="noStrike" cap="none">
+              <a:rPr lang="en-US" sz="1000" b="1" i="0" u="none" strike="noStrike" cap="none" dirty="0">
                 <a:solidFill>
                   <a:srgbClr val="E0E2E5"/>
                 </a:solidFill>
@@ -48736,7 +48818,7 @@
               <a:t>New methods:</a:t>
             </a:r>
             <a:r>
-              <a:rPr lang="en-US" sz="1000" b="0" i="0" u="none" strike="noStrike" cap="none">
+              <a:rPr lang="en-US" sz="1000" b="0" i="0" u="none" strike="noStrike" cap="none" dirty="0">
                 <a:solidFill>
                   <a:srgbClr val="E0E2E5"/>
                 </a:solidFill>
@@ -48747,7 +48829,7 @@
               </a:rPr>
               <a:t> POST, HEAD</a:t>
             </a:r>
-            <a:endParaRPr sz="1600" b="0" i="0" u="none" strike="noStrike" cap="none"/>
+            <a:endParaRPr sz="1600" b="0" i="0" u="none" strike="noStrike" cap="none" dirty="0"/>
           </a:p>
         </p:txBody>
       </p:sp>
@@ -48929,7 +49011,7 @@
               <a:buNone/>
             </a:pPr>
             <a:r>
-              <a:rPr lang="en-US" sz="1000" b="1" i="0" u="none" strike="noStrike" cap="none">
+              <a:rPr lang="en-US" sz="1000" b="1" i="0" u="none" strike="noStrike" cap="none" dirty="0">
                 <a:solidFill>
                   <a:srgbClr val="E0E2E5"/>
                 </a:solidFill>
@@ -48941,7 +49023,7 @@
               <a:t>Multimedia:</a:t>
             </a:r>
             <a:r>
-              <a:rPr lang="en-US" sz="1000" b="0" i="0" u="none" strike="noStrike" cap="none">
+              <a:rPr lang="en-US" sz="1000" b="0" i="0" u="none" strike="noStrike" cap="none" dirty="0">
                 <a:solidFill>
                   <a:srgbClr val="E0E2E5"/>
                 </a:solidFill>
@@ -48952,7 +49034,7 @@
               </a:rPr>
               <a:t> Images, CSS, JS</a:t>
             </a:r>
-            <a:endParaRPr sz="1600" b="0" i="0" u="none" strike="noStrike" cap="none"/>
+            <a:endParaRPr sz="1600" b="0" i="0" u="none" strike="noStrike" cap="none" dirty="0"/>
           </a:p>
         </p:txBody>
       </p:sp>
@@ -49134,7 +49216,7 @@
               <a:buNone/>
             </a:pPr>
             <a:r>
-              <a:rPr lang="en-US" sz="1000" b="1" i="0" u="none" strike="noStrike" cap="none">
+              <a:rPr lang="en-US" sz="1000" b="1" i="0" u="none" strike="noStrike" cap="none" dirty="0">
                 <a:solidFill>
                   <a:srgbClr val="E0E2E5"/>
                 </a:solidFill>
@@ -49146,7 +49228,7 @@
               <a:t>Headers:</a:t>
             </a:r>
             <a:r>
-              <a:rPr lang="en-US" sz="1000" b="0" i="0" u="none" strike="noStrike" cap="none">
+              <a:rPr lang="en-US" sz="1000" b="0" i="0" u="none" strike="noStrike" cap="none" dirty="0">
                 <a:solidFill>
                   <a:srgbClr val="E0E2E5"/>
                 </a:solidFill>
@@ -49157,7 +49239,7 @@
               </a:rPr>
               <a:t> Metadata support</a:t>
             </a:r>
-            <a:endParaRPr sz="1600" b="0" i="0" u="none" strike="noStrike" cap="none"/>
+            <a:endParaRPr sz="1600" b="0" i="0" u="none" strike="noStrike" cap="none" dirty="0"/>
           </a:p>
         </p:txBody>
       </p:sp>
@@ -49448,7 +49530,7 @@
               <a:buNone/>
             </a:pPr>
             <a:r>
-              <a:rPr lang="en-US" sz="1000" b="1" i="0" u="none" strike="noStrike" cap="none">
+              <a:rPr lang="en-US" sz="1000" b="1" i="0" u="none" strike="noStrike" cap="none" dirty="0">
                 <a:solidFill>
                   <a:srgbClr val="E0E2E5"/>
                 </a:solidFill>
@@ -49460,7 +49542,7 @@
               <a:t>Limitation:</a:t>
             </a:r>
             <a:r>
-              <a:rPr lang="en-US" sz="1000" b="0" i="0" u="none" strike="noStrike" cap="none">
+              <a:rPr lang="en-US" sz="1000" b="0" i="0" u="none" strike="noStrike" cap="none" dirty="0">
                 <a:solidFill>
                   <a:srgbClr val="E0E2E5"/>
                 </a:solidFill>
@@ -49469,9 +49551,36 @@
                 <a:cs typeface="Quattrocento Sans"/>
                 <a:sym typeface="Quattrocento Sans"/>
               </a:rPr>
-              <a:t> Still requires new TCP connection per request</a:t>
+              <a:t> Still </a:t>
             </a:r>
-            <a:endParaRPr sz="1600" b="0" i="0" u="none" strike="noStrike" cap="none"/>
+            <a:r>
+              <a:rPr lang="en-US" sz="1000" b="0" i="0" u="none" strike="noStrike" cap="none" dirty="0">
+                <a:solidFill>
+                  <a:srgbClr val="E0E2E5"/>
+                </a:solidFill>
+                <a:highlight>
+                  <a:srgbClr val="008000"/>
+                </a:highlight>
+                <a:latin typeface="Quattrocento Sans"/>
+                <a:ea typeface="Quattrocento Sans"/>
+                <a:cs typeface="Quattrocento Sans"/>
+                <a:sym typeface="Quattrocento Sans"/>
+              </a:rPr>
+              <a:t>requires new TCP connection per request  </a:t>
+            </a:r>
+            <a:r>
+              <a:rPr lang="en-US" sz="1000" b="0" i="0" u="none" strike="noStrike" cap="none" dirty="0">
+                <a:solidFill>
+                  <a:srgbClr val="E0E2E5"/>
+                </a:solidFill>
+                <a:latin typeface="Quattrocento Sans"/>
+                <a:ea typeface="Quattrocento Sans"/>
+                <a:cs typeface="Quattrocento Sans"/>
+                <a:sym typeface="Quattrocento Sans"/>
+              </a:rPr>
+              <a:t> (Each req 3 way handshake)</a:t>
+            </a:r>
+            <a:endParaRPr sz="1600" b="0" i="0" u="none" strike="noStrike" cap="none" dirty="0"/>
           </a:p>
         </p:txBody>
       </p:sp>

</xml_diff>

<commit_message>
http Version Selection in TCP IP Layers Elaborate, other http concept udated
</commit_message>
<xml_diff>
--- a/network/sir-slides/3. HTTP Protocol_ From Fundamentals to Modern Evolution.pptx
+++ b/network/sir-slides/3. HTTP Protocol_ From Fundamentals to Modern Evolution.pptx
@@ -281,7 +281,7 @@
       <p15:sldGuideLst xmlns:p15="http://schemas.microsoft.com/office/powerpoint/2012/main"/>
     </p:ext>
     <p:ext uri="GoogleSlidesCustomDataVersion2">
-      <go:slidesCustomData xmlns="" xmlns:mc="http://schemas.openxmlformats.org/markup-compatibility/2006" xmlns:mv="urn:schemas-microsoft-com:mac:vml" xmlns:c="http://schemas.openxmlformats.org/drawingml/2006/chart" xmlns:dgm="http://schemas.openxmlformats.org/drawingml/2006/diagram" xmlns:o="urn:schemas-microsoft-com:office:office" xmlns:v="urn:schemas-microsoft-com:vml" xmlns:pvml="urn:schemas-microsoft-com:office:powerpoint" xmlns:com="http://schemas.openxmlformats.org/drawingml/2006/compatibility" xmlns:p14="http://schemas.microsoft.com/office/powerpoint/2010/main" xmlns:p15="http://schemas.microsoft.com/office/powerpoint/2012/main" xmlns:ahyp="http://schemas.microsoft.com/office/drawing/2018/hyperlinkcolor" xmlns:go="http://customooxmlschemas.google.com/" r:id="rId26" roundtripDataSignature="AMtx7mgnoFNwFO5TLHagq12mb4X6f1mkKw=="/>
+      <go:slidesCustomData xmlns:go="http://customooxmlschemas.google.com/" xmlns:ahyp="http://schemas.microsoft.com/office/drawing/2018/hyperlinkcolor" xmlns:p15="http://schemas.microsoft.com/office/powerpoint/2012/main" xmlns:p14="http://schemas.microsoft.com/office/powerpoint/2010/main" xmlns:com="http://schemas.openxmlformats.org/drawingml/2006/compatibility" xmlns:pvml="urn:schemas-microsoft-com:office:powerpoint" xmlns:v="urn:schemas-microsoft-com:vml" xmlns:o="urn:schemas-microsoft-com:office:office" xmlns:dgm="http://schemas.openxmlformats.org/drawingml/2006/diagram" xmlns:c="http://schemas.openxmlformats.org/drawingml/2006/chart" xmlns:mv="urn:schemas-microsoft-com:mac:vml" xmlns:mc="http://schemas.openxmlformats.org/markup-compatibility/2006" xmlns="" r:id="rId26" roundtripDataSignature="AMtx7mgnoFNwFO5TLHagq12mb4X6f1mkKw=="/>
     </p:ext>
   </p:extLst>
 </p:presentation>
@@ -12783,6 +12783,18 @@
               <a:buNone/>
             </a:pPr>
             <a:r>
+              <a:rPr lang="en-US" sz="1284" b="1" i="0" u="none" strike="noStrike" cap="none" dirty="0">
+                <a:solidFill>
+                  <a:srgbClr val="E0E2E5"/>
+                </a:solidFill>
+                <a:latin typeface="Liter"/>
+                <a:ea typeface="Liter"/>
+                <a:cs typeface="Liter"/>
+                <a:sym typeface="Liter"/>
+              </a:rPr>
+              <a:t>Server Push (Server </a:t>
+            </a:r>
+            <a:r>
               <a:rPr lang="en-US" sz="1284" b="1" i="0" u="none" strike="noStrike" cap="none">
                 <a:solidFill>
                   <a:srgbClr val="E0E2E5"/>
@@ -12792,9 +12804,25 @@
                 <a:cs typeface="Liter"/>
                 <a:sym typeface="Liter"/>
               </a:rPr>
-              <a:t>Server Push</a:t>
+              <a:t>Sent Events ?? ) </a:t>
             </a:r>
-            <a:endParaRPr sz="1600" b="0" i="0" u="none" strike="noStrike" cap="none"/>
+            <a:r>
+              <a:rPr lang="en-US" sz="1284" b="1" i="0" u="none" strike="noStrike" cap="none" dirty="0">
+                <a:solidFill>
+                  <a:srgbClr val="92D050"/>
+                </a:solidFill>
+                <a:latin typeface="Liter"/>
+                <a:ea typeface="Liter"/>
+                <a:cs typeface="Liter"/>
+                <a:sym typeface="Liter"/>
+              </a:rPr>
+              <a:t>*** IMP</a:t>
+            </a:r>
+            <a:endParaRPr sz="1600" b="0" i="0" u="none" strike="noStrike" cap="none" dirty="0">
+              <a:solidFill>
+                <a:srgbClr val="92D050"/>
+              </a:solidFill>
+            </a:endParaRPr>
           </a:p>
         </p:txBody>
       </p:sp>
@@ -21744,7 +21772,7 @@
         </p:nvGraphicFramePr>
         <p:xfrm>
           <a:off x="612427" y="1564043"/>
-          <a:ext cx="3000000" cy="3000000"/>
+          <a:ext cx="10967175" cy="4654500"/>
         </p:xfrm>
         <a:graphic>
           <a:graphicData uri="http://schemas.openxmlformats.org/drawingml/2006/table">

</xml_diff>

<commit_message>
networking for devs will start
</commit_message>
<xml_diff>
--- a/network/sir-slides/3. HTTP Protocol_ From Fundamentals to Modern Evolution.pptx
+++ b/network/sir-slides/3. HTTP Protocol_ From Fundamentals to Modern Evolution.pptx
@@ -12792,10 +12792,37 @@
                 <a:cs typeface="Liter"/>
                 <a:sym typeface="Liter"/>
               </a:rPr>
-              <a:t>Server Push (Server </a:t>
+              <a:t>Server Push (</a:t>
             </a:r>
             <a:r>
-              <a:rPr lang="en-US" sz="1284" b="1" i="0" u="none" strike="noStrike" cap="none">
+              <a:rPr lang="en-US" sz="1284" b="1" i="0" u="none" strike="noStrike" cap="none" dirty="0">
+                <a:solidFill>
+                  <a:srgbClr val="E0E2E5"/>
+                </a:solidFill>
+                <a:highlight>
+                  <a:srgbClr val="FF0000"/>
+                </a:highlight>
+                <a:latin typeface="Liter"/>
+                <a:ea typeface="Liter"/>
+                <a:cs typeface="Liter"/>
+                <a:sym typeface="Liter"/>
+              </a:rPr>
+              <a:t>Server Sent Events </a:t>
+            </a:r>
+            <a:r>
+              <a:rPr lang="en-US" sz="1284" b="1" i="0" u="none" strike="noStrike" cap="none" dirty="0">
+                <a:solidFill>
+                  <a:srgbClr val="FF0000"/>
+                </a:solidFill>
+                <a:latin typeface="Liter"/>
+                <a:ea typeface="Liter"/>
+                <a:cs typeface="Liter"/>
+                <a:sym typeface="Liter"/>
+              </a:rPr>
+              <a:t>?? </a:t>
+            </a:r>
+            <a:r>
+              <a:rPr lang="en-US" sz="1284" b="1" i="0" u="none" strike="noStrike" cap="none" dirty="0">
                 <a:solidFill>
                   <a:srgbClr val="E0E2E5"/>
                 </a:solidFill>
@@ -12804,7 +12831,7 @@
                 <a:cs typeface="Liter"/>
                 <a:sym typeface="Liter"/>
               </a:rPr>
-              <a:t>Sent Events ?? ) </a:t>
+              <a:t>) </a:t>
             </a:r>
             <a:r>
               <a:rPr lang="en-US" sz="1284" b="1" i="0" u="none" strike="noStrike" cap="none" dirty="0">
@@ -15913,7 +15940,7 @@
               <a:buNone/>
             </a:pPr>
             <a:r>
-              <a:rPr lang="en-US" sz="1141" b="0" i="0" u="none" strike="noStrike" cap="none">
+              <a:rPr lang="en-US" sz="1141" b="0" i="0" u="none" strike="noStrike" cap="none" dirty="0">
                 <a:solidFill>
                   <a:srgbClr val="E0E2E5"/>
                 </a:solidFill>
@@ -15925,7 +15952,7 @@
               <a:t>HTTP/2 still uses TCP—if one packet is lost, TCP stops all streams until retransmission. </a:t>
             </a:r>
             <a:r>
-              <a:rPr lang="en-US" sz="1141" b="1" i="0" u="none" strike="noStrike" cap="none">
+              <a:rPr lang="en-US" sz="1141" b="1" i="0" u="none" strike="noStrike" cap="none" dirty="0">
                 <a:solidFill>
                   <a:srgbClr val="B89A6B"/>
                 </a:solidFill>
@@ -15936,7 +15963,7 @@
               </a:rPr>
               <a:t>HTTP/3 solves this with QUIC.</a:t>
             </a:r>
-            <a:endParaRPr sz="1600" b="0" i="0" u="none" strike="noStrike" cap="none"/>
+            <a:endParaRPr sz="1600" b="0" i="0" u="none" strike="noStrike" cap="none" dirty="0"/>
           </a:p>
         </p:txBody>
       </p:sp>
@@ -21768,7 +21795,13 @@
         <p:nvGraphicFramePr>
           <p:cNvPr id="578" name="Google Shape;578;p13"/>
           <p:cNvGraphicFramePr/>
-          <p:nvPr/>
+          <p:nvPr>
+            <p:extLst>
+              <p:ext uri="{D42A27DB-BD31-4B8C-83A1-F6EECF244321}">
+                <p14:modId xmlns:p14="http://schemas.microsoft.com/office/powerpoint/2010/main" val="2505573426"/>
+              </p:ext>
+            </p:extLst>
+          </p:nvPr>
         </p:nvGraphicFramePr>
         <p:xfrm>
           <a:off x="612427" y="1564043"/>
@@ -23410,7 +23443,7 @@
                         <a:buNone/>
                       </a:pPr>
                       <a:r>
-                        <a:rPr lang="en-US" sz="1100" b="1" u="none">
+                        <a:rPr lang="en-US" sz="1100" b="1" u="none" dirty="0">
                           <a:solidFill>
                             <a:srgbClr val="E0E2E5"/>
                           </a:solidFill>
@@ -23421,7 +23454,7 @@
                         </a:rPr>
                         <a:t>Multiplexing</a:t>
                       </a:r>
-                      <a:endParaRPr sz="1100">
+                      <a:endParaRPr sz="1100" dirty="0">
                         <a:latin typeface="Microsoft Yahei"/>
                         <a:ea typeface="Microsoft Yahei"/>
                         <a:cs typeface="Microsoft Yahei"/>
@@ -23873,7 +23906,7 @@
                         <a:buNone/>
                       </a:pPr>
                       <a:r>
-                        <a:rPr lang="en-US" sz="1100" b="1" u="none">
+                        <a:rPr lang="en-US" sz="1100" b="1" u="none" dirty="0">
                           <a:solidFill>
                             <a:srgbClr val="E0E2E5"/>
                           </a:solidFill>
@@ -23884,7 +23917,7 @@
                         </a:rPr>
                         <a:t>Header Compression</a:t>
                       </a:r>
-                      <a:endParaRPr sz="1100">
+                      <a:endParaRPr sz="1100" dirty="0">
                         <a:latin typeface="Microsoft Yahei"/>
                         <a:ea typeface="Microsoft Yahei"/>
                         <a:cs typeface="Microsoft Yahei"/>
@@ -24880,9 +24913,9 @@
                           <a:cs typeface="Microsoft Yahei"/>
                           <a:sym typeface="Microsoft Yahei"/>
                         </a:rPr>
-                        <a:t>HOL Blocking</a:t>
+                        <a:t>HOL (Head-of-line )Blocking</a:t>
                       </a:r>
-                      <a:endParaRPr sz="1100">
+                      <a:endParaRPr sz="1100" dirty="0">
                         <a:latin typeface="Microsoft Yahei"/>
                         <a:ea typeface="Microsoft Yahei"/>
                         <a:cs typeface="Microsoft Yahei"/>
@@ -26750,7 +26783,7 @@
                         <a:buNone/>
                       </a:pPr>
                       <a:r>
-                        <a:rPr lang="en-US" sz="1100" u="none">
+                        <a:rPr lang="en-US" sz="1100" u="none" dirty="0">
                           <a:solidFill>
                             <a:srgbClr val="E0E2E5"/>
                           </a:solidFill>
@@ -26761,7 +26794,7 @@
                         </a:rPr>
                         <a:t>Fastest</a:t>
                       </a:r>
-                      <a:endParaRPr sz="1100">
+                      <a:endParaRPr sz="1100" dirty="0">
                         <a:latin typeface="Microsoft Yahei"/>
                         <a:ea typeface="Microsoft Yahei"/>
                         <a:cs typeface="Microsoft Yahei"/>

</xml_diff>